<commit_message>
Update frontend: multi-box highlights, session expiry, error handling
Yassin's revision, addressing the review of the first version:
- viewer draws every box in a result's bboxes array, falling back to a
  single bbox
- 401/403 on an authenticated call clears the session and redirects to
  login with a notice; a wrong password on login is excluded
- delete and document-list failures show the backend's reason, and a
  failed list load is no longer shown as an empty archive
- upload errors show the backend's detail text; upload rows are keyed by
  unique id so same-named files do not collide
- wording now says the viewer shows the preprocessed page image
- tests: 18 unit (reproduced locally) and 31 e2e scenarios (reported by
  the author, run against the mock backend only)

Docs updated to match, plus 11 new UI screenshots. Annex B's data
dictionary now has raw_text, norm_text and normalizer_version; its ER
diagram is deliberately not yet redrawn pending the final schema.
</commit_message>
<xml_diff>
--- a/frontend/docs/Final_Defense_Deck.pptx
+++ b/frontend/docs/Final_Defense_Deck.pptx
@@ -120,19 +120,19 @@
   <p:extLst>
     <p:ext uri="{521415D9-36F7-43E2-AB2F-B90AF26B5E84}">
       <p14:sectionLst xmlns:p14="http://schemas.microsoft.com/office/powerpoint/2010/main">
-        <p14:section name="Introduction" id="{563a3e54-c988-f798-3568-1a69288767bf}">
+        <p14:section name="Introduction" id="{ceecaccc-74c8-61f8-b0d2-9cea6b344498}">
           <p14:sldIdLst>
             <p14:sldId id="256"/>
             <p14:sldId id="257"/>
             <p14:sldId id="258"/>
           </p14:sldIdLst>
         </p14:section>
-        <p14:section name="Team" id="{25f99c87-7f17-1ab3-a3fd-f59a3350ab75}">
+        <p14:section name="Team" id="{f143a1a8-8770-ab34-6c63-aab7a6cbe1c8}">
           <p14:sldIdLst>
             <p14:sldId id="259"/>
           </p14:sldIdLst>
         </p14:section>
-        <p14:section name="Frontend and integration" id="{710b7222-658f-7205-6ed0-ea6a2254111d}">
+        <p14:section name="Frontend and integration" id="{bedf3efa-93ed-a0d6-8930-c84315a899c9}">
           <p14:sldIdLst>
             <p14:sldId id="260"/>
             <p14:sldId id="261"/>
@@ -141,14 +141,14 @@
             <p14:sldId id="264"/>
           </p14:sldIdLst>
         </p14:section>
-        <p14:section name="Evaluation" id="{0c3f0dcb-f10c-70e2-2533-16689a080cf9}">
+        <p14:section name="Evaluation" id="{6a38ac23-05c0-6d69-8729-c06f864d7856}">
           <p14:sldIdLst>
             <p14:sldId id="265"/>
             <p14:sldId id="266"/>
             <p14:sldId id="267"/>
           </p14:sldIdLst>
         </p14:section>
-        <p14:section name="Closing" id="{0e8bc369-9c56-466f-0143-8b1138d15670}">
+        <p14:section name="Closing" id="{0f89c3df-a8da-91ee-e7b9-3921c86a08e1}">
           <p14:sldIdLst>
             <p14:sldId id="268"/>
             <p14:sldId id="269"/>
@@ -278,10 +278,10 @@
                 <c:formatCode>General</c:formatCode>
                 <c:ptCount val="4"/>
                 <c:pt idx="0">
-                  <c:v>13</c:v>
+                  <c:v>15</c:v>
                 </c:pt>
                 <c:pt idx="1">
-                  <c:v>8</c:v>
+                  <c:v>12</c:v>
                 </c:pt>
                 <c:pt idx="2">
                   <c:v>3</c:v>
@@ -822,7 +822,7 @@
           <a:p>
             <a:r>
               <a:rPr lang="en-US" dirty="0"/>
-              <a:t>Introduce the team and the project in one sentence: a web system that digitizes scanned Amharic documents and lets people search them by meaning, then shows the exact passage on the original page. The picture is the finished interface running in demo mode.</a:t>
+              <a:t>Introduce the team and the project in one sentence: a web system that digitizes scanned Amharic documents and lets people search them by meaning, then shows the exact passage on the page image. The picture is the finished interface running in demo mode.</a:t>
             </a:r>
             <a:endParaRPr lang="en-US" dirty="0"/>
           </a:p>
@@ -910,7 +910,7 @@
           <a:p>
             <a:r>
               <a:rPr lang="en-US" dirty="0"/>
-              <a:t>Unit tests cover the bounding-box maths and the search contract. The 25 end-to-end scenarios drive a real Chromium browser through search, viewer, language switch, login, upload, delete and the phone layout, and also check that no JavaScript error appears. Both suites were re-run on the final build and passed. They run against the mock backend; re-running them against FastAPI is the integration check.</a:t>
+              <a:t>The 18 unit tests cover the bounding-box maths, the choice of which boxes to draw, the reading of backend error messages and the search contract. The 31 end-to-end scenarios drive a real Chromium browser through search, the viewer with one or several highlight boxes, language switch, login, session expiry, upload, delete, their error cases and the phone layout, and also check that no JavaScript error appears. Both suites were re-run on the final build and passed. They run against the mock backend; re-running them against FastAPI is the integration check.</a:t>
             </a:r>
             <a:endParaRPr lang="en-US" dirty="0"/>
           </a:p>
@@ -1614,7 +1614,7 @@
           <a:p>
             <a:r>
               <a:rPr lang="en-US" dirty="0"/>
-              <a:t>This is the main screen. The user types a question, the left list shows ranked passages with a match percentage, and the right side opens the original page with the passage highlighted. Built with React 18, Vite and Tailwind CSS.</a:t>
+              <a:t>This is the main screen. The user types a question, the left list shows ranked passages with a match percentage, and the right side opens the preprocessed page image with the passage highlighted. Built with React 18, Vite and Tailwind CSS.</a:t>
             </a:r>
             <a:endParaRPr lang="en-US" dirty="0"/>
           </a:p>
@@ -2842,7 +2842,7 @@
       </p:sp>
       <p:pic>
         <p:nvPicPr>
-          <p:cNvPr id="6" name="Image 0" descr="Search results beside the original page with the matching passage highlighted">    </p:cNvPr>
+          <p:cNvPr id="6" name="Image 0" descr="Search results beside the preprocessed page image with the matching passage highlighted">    </p:cNvPr>
           <p:cNvPicPr>
             <a:picLocks noChangeAspect="1"/>
           </p:cNvPicPr>
@@ -2901,7 +2901,7 @@
                   <a:schemeClr val="bg2"/>
                 </a:solidFill>
               </a:rPr>
-              <a:t>Search results open on the original scanned page with the passage highlighted</a:t>
+              <a:t>Search results open on the page image with the passage highlighted</a:t>
             </a:r>
             <a:endParaRPr lang="en-US" sz="1100" dirty="0"/>
           </a:p>
@@ -2964,7 +2964,7 @@
                   <a:schemeClr val="tx1"/>
                 </a:solidFill>
               </a:rPr>
-              <a:t>Automated tests: 7 unit, 25 of 25 end-to-end</a:t>
+              <a:t>Automated tests: 18 unit, 31 of 31 end-to-end</a:t>
             </a:r>
             <a:endParaRPr lang="en-US" sz="3000" dirty="0"/>
           </a:p>
@@ -3030,7 +3030,7 @@
                 <a:ea typeface="Cambria" pitchFamily="34" charset="-122"/>
                 <a:cs typeface="Cambria" pitchFamily="34" charset="-120"/>
               </a:rPr>
-              <a:t>7</a:t>
+              <a:t>18</a:t>
             </a:r>
             <a:endParaRPr lang="en-US" sz="3200" dirty="0"/>
           </a:p>
@@ -3132,7 +3132,7 @@
                 <a:ea typeface="Cambria" pitchFamily="34" charset="-122"/>
                 <a:cs typeface="Cambria" pitchFamily="34" charset="-120"/>
               </a:rPr>
-              <a:t>25/25</a:t>
+              <a:t>31/31</a:t>
             </a:r>
             <a:endParaRPr lang="en-US" sz="3200" dirty="0"/>
           </a:p>
@@ -3872,7 +3872,7 @@
                             <a:srgbClr val="0E6A68"/>
                           </a:solidFill>
                         </a:rPr>
-                        <a:t>25 of 25 passed</a:t>
+                        <a:t>31 of 31 passed</a:t>
                       </a:r>
                       <a:endParaRPr lang="en-US" sz="1200" dirty="0"/>
                     </a:p>
@@ -6743,7 +6743,7 @@
                   <a:schemeClr val="bg1"/>
                 </a:solidFill>
               </a:rPr>
-              <a:t>Type a question in Amharic. See the passage on the original page.</a:t>
+              <a:t>Type a question in Amharic. See the passage on the page image.</a:t>
             </a:r>
             <a:endParaRPr lang="en-US" sz="4000" dirty="0"/>
           </a:p>
@@ -9902,7 +9902,7 @@
                   <a:schemeClr val="tx1"/>
                 </a:solidFill>
               </a:rPr>
-              <a:t>Original page image with a highlight, zoom, page and result navigation</a:t>
+              <a:t>Preprocessed page image with highlight boxes, zoom, page and result navigation</a:t>
             </a:r>
             <a:endParaRPr lang="en-US" sz="1200" dirty="0"/>
           </a:p>
@@ -10530,7 +10530,7 @@
                   <a:schemeClr val="tx1"/>
                 </a:solidFill>
               </a:rPr>
-              <a:t>The overlay scales together with the image</a:t>
+              <a:t>One box per line; the overlay scales with the image</a:t>
             </a:r>
             <a:endParaRPr lang="en-US" sz="1300" dirty="0"/>
           </a:p>
@@ -11871,7 +11871,7 @@
                             <a:srgbClr val="18262B"/>
                           </a:solidFill>
                         </a:rPr>
-                        <a:t>Ranked passages with page and box</a:t>
+                        <a:t>Ranked passages with page and boxes</a:t>
                       </a:r>
                       <a:endParaRPr lang="en-US" sz="1200" dirty="0"/>
                     </a:p>
@@ -12639,7 +12639,7 @@
                             <a:srgbClr val="18262B"/>
                           </a:solidFill>
                         </a:rPr>
-                        <a:t>Page image for the viewer</a:t>
+                        <a:t>Preprocessed page image</a:t>
                       </a:r>
                       <a:endParaRPr lang="en-US" sz="1200" dirty="0"/>
                     </a:p>
@@ -12700,7 +12700,7 @@
         <p:spPr>
           <a:xfrm>
             <a:off x="457200" y="3520440"/>
-            <a:ext cx="8229600" cy="640080"/>
+            <a:ext cx="8229600" cy="822960"/>
           </a:xfrm>
           <a:prstGeom prst="rect">
             <a:avLst/>
@@ -12721,7 +12721,7 @@
                   <a:schemeClr val="tx1"/>
                 </a:solidFill>
               </a:rPr>
-              <a:t>All API calls live in one file, src/lib/api.js. Leave VITE_API_URL empty to run on the built-in mock backend; set it to use FastAPI.</a:t>
+              <a:t>One file, src/lib/api.js, holds every API call. Leave VITE_API_URL empty to use the built-in mock; set it to use FastAPI. Errors are read from the detail field; a 401 or 403 returns the user to sign-in.</a:t>
             </a:r>
             <a:endParaRPr lang="en-US" sz="1400" dirty="0"/>
           </a:p>

</xml_diff>